<commit_message>
refactor: reshape PPT around project management skills
Co-authored-by: liulizhizi <108928352+liulizhizi@users.noreply.github.com>
</commit_message>
<xml_diff>
--- a/Transformer-Based Sustain Pedal Reconstruction for Expressive Piano Performance.pptx
+++ b/Transformer-Based Sustain Pedal Reconstruction for Expressive Piano Performance.pptx
@@ -3437,35 +3437,15 @@
           </a:xfrm>
         </p:spPr>
         <p:txBody>
-          <a:bodyPr rtlCol="0" anchor="ctr" anchorCtr="0">
+          <a:bodyPr rtlCol="0" anchor="ctr" anchorCtr="0" wrap="square">
             <a:normAutofit/>
           </a:bodyPr>
           <a:lstStyle/>
           <a:p>
             <a:pPr algn="ctr"/>
             <a:r>
-              <a:rPr lang="zh-CN" altLang="en-US" sz="4800" dirty="0">
-                <a:solidFill>
-                  <a:schemeClr val="bg1"/>
-                </a:solidFill>
-              </a:rPr>
-              <a:t>基于</a:t>
-            </a:r>
-            <a:r>
-              <a:rPr lang="en-US" altLang="zh-CN" sz="4800" dirty="0">
-                <a:solidFill>
-                  <a:schemeClr val="bg1"/>
-                </a:solidFill>
-              </a:rPr>
-              <a:t>transformer</a:t>
-            </a:r>
-            <a:r>
-              <a:rPr lang="zh-CN" altLang="en-US" sz="4800" dirty="0">
-                <a:solidFill>
-                  <a:schemeClr val="bg1"/>
-                </a:solidFill>
-              </a:rPr>
-              <a:t>的钢琴踏板重建</a:t>
+              <a:rPr sz="3000" b="1"/>
+              <a:t>项目管理与项目规划能力展示</a:t>
             </a:r>
             <a:endParaRPr lang="en-US" altLang="zh-CN" sz="4800" dirty="0">
               <a:solidFill>
@@ -3492,21 +3472,15 @@
           </a:xfrm>
         </p:spPr>
         <p:txBody>
-          <a:bodyPr rtlCol="0">
+          <a:bodyPr rtlCol="0" wrap="square">
             <a:normAutofit/>
           </a:bodyPr>
           <a:lstStyle/>
           <a:p>
             <a:pPr algn="ctr"/>
             <a:r>
-              <a:rPr lang="zh-CN" altLang="en-US" sz="2400" dirty="0">
-                <a:solidFill>
-                  <a:schemeClr val="bg1"/>
-                </a:solidFill>
-                <a:latin typeface="Microsoft YaHei UI Light" panose="020B0502040204020203" pitchFamily="34" charset="-122"/>
-                <a:ea typeface="Microsoft YaHei UI Light" panose="020B0502040204020203" pitchFamily="34" charset="-122"/>
-              </a:rPr>
-              <a:t>刘文昊</a:t>
+              <a:rPr sz="1800"/>
+              <a:t>结构版（先定框架，后补案例与数据）</a:t>
             </a:r>
           </a:p>
         </p:txBody>
@@ -3565,46 +3539,87 @@
         </p:nvSpPr>
         <p:spPr/>
         <p:txBody>
-          <a:bodyPr/>
+          <a:bodyPr wrap="square"/>
           <a:lstStyle/>
           <a:p>
             <a:r>
-              <a:rPr lang="zh-CN" altLang="en-US" dirty="0"/>
-              <a:t>评估与结果</a:t>
-            </a:r>
-          </a:p>
-        </p:txBody>
-      </p:sp>
-      <p:pic>
-        <p:nvPicPr>
-          <p:cNvPr id="4" name="图片 3">
-            <a:extLst>
-              <a:ext uri="{FF2B5EF4-FFF2-40B4-BE49-F238E27FC236}">
-                <a16:creationId xmlns:a16="http://schemas.microsoft.com/office/drawing/2014/main" id="{996D3527-D8F5-9B15-5E89-4192F8A52D8E}"/>
-              </a:ext>
-            </a:extLst>
-          </p:cNvPr>
-          <p:cNvPicPr>
-            <a:picLocks noChangeAspect="1"/>
-          </p:cNvPicPr>
+              <a:rPr sz="2800" b="1"/>
+              <a:t>代表项目案例页结构</a:t>
+            </a:r>
+          </a:p>
+        </p:txBody>
+      </p:sp>
+      <p:sp>
+        <p:nvSpPr>
+          <p:cNvPr id="4" name="TextBox 3"/>
+          <p:cNvSpPr txBox="1"/>
           <p:nvPr/>
-        </p:nvPicPr>
-        <p:blipFill>
-          <a:blip r:embed="rId3"/>
-          <a:stretch>
-            <a:fillRect/>
-          </a:stretch>
-        </p:blipFill>
+        </p:nvSpPr>
         <p:spPr>
           <a:xfrm>
-            <a:off x="1420644" y="1619084"/>
-            <a:ext cx="7423940" cy="4128111"/>
+            <a:off x="868680" y="1325880"/>
+            <a:ext cx="10332720" cy="4480560"/>
           </a:xfrm>
           <a:prstGeom prst="rect">
             <a:avLst/>
           </a:prstGeom>
+          <a:noFill/>
         </p:spPr>
-      </p:pic>
+        <p:txBody>
+          <a:bodyPr wrap="square">
+            <a:spAutoFit/>
+          </a:bodyPr>
+          <a:lstStyle/>
+          <a:p>
+            <a:r>
+              <a:rPr sz="2400"/>
+              <a:t>• 项目背景 / 目标：为什么做、做成什么</a:t>
+            </a:r>
+          </a:p>
+          <a:p>
+            <a:pPr>
+              <a:spcBef>
+                <a:spcPts val="0"/>
+              </a:spcBef>
+              <a:spcAft>
+                <a:spcPts val="800"/>
+              </a:spcAft>
+            </a:pPr>
+            <a:r>
+              <a:rPr sz="2400"/>
+              <a:t>• 我的角色 / 管理动作：如何推动项目落地</a:t>
+            </a:r>
+          </a:p>
+          <a:p>
+            <a:pPr>
+              <a:spcBef>
+                <a:spcPts val="0"/>
+              </a:spcBef>
+              <a:spcAft>
+                <a:spcPts val="800"/>
+              </a:spcAft>
+            </a:pPr>
+            <a:r>
+              <a:rPr sz="2400"/>
+              <a:t>• 计划安排 / 风险协调：如何保证按节点推进</a:t>
+            </a:r>
+          </a:p>
+          <a:p>
+            <a:pPr>
+              <a:spcBef>
+                <a:spcPts val="0"/>
+              </a:spcBef>
+              <a:spcAft>
+                <a:spcPts val="800"/>
+              </a:spcAft>
+            </a:pPr>
+            <a:r>
+              <a:rPr sz="2400"/>
+              <a:t>• 结果与复盘：产出、指标、经验与方法沉淀</a:t>
+            </a:r>
+          </a:p>
+        </p:txBody>
+      </p:sp>
     </p:spTree>
     <p:extLst>
       <p:ext uri="{BB962C8B-B14F-4D97-AF65-F5344CB8AC3E}">
@@ -3667,32 +3682,26 @@
         </p:nvSpPr>
         <p:spPr/>
         <p:txBody>
-          <a:bodyPr/>
+          <a:bodyPr wrap="square"/>
           <a:lstStyle/>
           <a:p>
             <a:r>
-              <a:rPr lang="zh-CN" altLang="en-US" dirty="0"/>
-              <a:t>总结与展望</a:t>
-            </a:r>
-          </a:p>
-        </p:txBody>
-      </p:sp>
-      <p:sp>
-        <p:nvSpPr>
-          <p:cNvPr id="6" name="文本框 5">
-            <a:extLst>
-              <a:ext uri="{FF2B5EF4-FFF2-40B4-BE49-F238E27FC236}">
-                <a16:creationId xmlns:a16="http://schemas.microsoft.com/office/drawing/2014/main" id="{0D9E9121-62B2-D5D6-6BD9-BC1889E19018}"/>
-              </a:ext>
-            </a:extLst>
-          </p:cNvPr>
+              <a:rPr sz="2800" b="1"/>
+              <a:t>下一步细化内容</a:t>
+            </a:r>
+          </a:p>
+        </p:txBody>
+      </p:sp>
+      <p:sp>
+        <p:nvSpPr>
+          <p:cNvPr id="4" name="TextBox 3"/>
           <p:cNvSpPr txBox="1"/>
           <p:nvPr/>
         </p:nvSpPr>
         <p:spPr>
           <a:xfrm>
-            <a:off x="741973" y="1951672"/>
-            <a:ext cx="6097656" cy="1477328"/>
+            <a:off x="868680" y="1325880"/>
+            <a:ext cx="10332720" cy="4480560"/>
           </a:xfrm>
           <a:prstGeom prst="rect">
             <a:avLst/>
@@ -3706,26 +3715,36 @@
           <a:lstStyle/>
           <a:p>
             <a:r>
-              <a:rPr lang="zh-CN" altLang="en-US" dirty="0"/>
-              <a:t>将踏板功能整合到音符特性中：将踏板视为音符属性的一部分，而非独立的事件。</a:t>
-            </a:r>
-            <a:endParaRPr lang="en-US" altLang="zh-CN" dirty="0"/>
-          </a:p>
-          <a:p>
-            <a:endParaRPr lang="en-US" altLang="zh-CN" dirty="0"/>
-          </a:p>
-          <a:p>
-            <a:r>
-              <a:rPr lang="zh-CN" altLang="en-US" dirty="0"/>
-              <a:t>优化模型效率：探索轻量级的 </a:t>
-            </a:r>
-            <a:r>
-              <a:rPr lang="en-US" altLang="zh-CN" dirty="0"/>
-              <a:t>Transformer </a:t>
-            </a:r>
-            <a:r>
-              <a:rPr lang="zh-CN" altLang="en-US" dirty="0"/>
-              <a:t>架构或多模态架构。</a:t>
+              <a:rPr sz="2400"/>
+              <a:t>• 每个模块补 1~2 个真实项目案例</a:t>
+            </a:r>
+          </a:p>
+          <a:p>
+            <a:pPr>
+              <a:spcBef>
+                <a:spcPts val="0"/>
+              </a:spcBef>
+              <a:spcAft>
+                <a:spcPts val="800"/>
+              </a:spcAft>
+            </a:pPr>
+            <a:r>
+              <a:rPr sz="2400"/>
+              <a:t>• 增加量化结果：周期、效率、成本、满意度等指标</a:t>
+            </a:r>
+          </a:p>
+          <a:p>
+            <a:pPr>
+              <a:spcBef>
+                <a:spcPts val="0"/>
+              </a:spcBef>
+              <a:spcAft>
+                <a:spcPts val="800"/>
+              </a:spcAft>
+            </a:pPr>
+            <a:r>
+              <a:rPr sz="2400"/>
+              <a:t>• 提炼个人优势：项目管理风格、规划能力、协同亮点</a:t>
             </a:r>
           </a:p>
         </p:txBody>
@@ -3768,32 +3787,6 @@
           <a:chExt cx="0" cy="0"/>
         </a:xfrm>
       </p:grpSpPr>
-      <p:pic>
-        <p:nvPicPr>
-          <p:cNvPr id="5" name="图片 4"/>
-          <p:cNvPicPr>
-            <a:picLocks noChangeAspect="1"/>
-          </p:cNvPicPr>
-          <p:nvPr/>
-        </p:nvPicPr>
-        <p:blipFill rotWithShape="1">
-          <a:blip r:embed="rId3"/>
-          <a:srcRect t="6101" b="6101"/>
-          <a:stretch/>
-        </p:blipFill>
-        <p:spPr>
-          <a:xfrm>
-            <a:off x="4976037" y="1385113"/>
-            <a:ext cx="6513229" cy="4577621"/>
-          </a:xfrm>
-          <a:prstGeom prst="rect">
-            <a:avLst/>
-          </a:prstGeom>
-          <a:effectLst>
-            <a:softEdge rad="635000"/>
-          </a:effectLst>
-        </p:spPr>
-      </p:pic>
       <p:sp>
         <p:nvSpPr>
           <p:cNvPr id="8" name="标题 7"/>
@@ -3806,14 +3799,14 @@
         </p:nvSpPr>
         <p:spPr/>
         <p:txBody>
-          <a:bodyPr rtlCol="0">
+          <a:bodyPr rtlCol="0" wrap="square">
             <a:noAutofit/>
           </a:bodyPr>
           <a:lstStyle/>
           <a:p>
             <a:r>
-              <a:rPr lang="zh-CN" altLang="en-US" sz="3200" dirty="0"/>
-              <a:t>动机</a:t>
+              <a:rPr sz="2800" b="1"/>
+              <a:t>展示目标与核心定位</a:t>
             </a:r>
             <a:endParaRPr lang="zh-CN" altLang="en-US" sz="3200" dirty="0">
               <a:cs typeface="Segoe UI Light" panose="020B0502040204020203" pitchFamily="34" charset="0"/>
@@ -3823,251 +3816,14 @@
       </p:sp>
       <p:sp>
         <p:nvSpPr>
-          <p:cNvPr id="38" name="内容占位符 17"/>
-          <p:cNvSpPr txBox="1">
-            <a:spLocks/>
-          </p:cNvSpPr>
+          <p:cNvPr id="9" name="TextBox 8"/>
+          <p:cNvSpPr txBox="1"/>
           <p:nvPr/>
         </p:nvSpPr>
         <p:spPr>
           <a:xfrm>
-            <a:off x="541610" y="1524708"/>
-            <a:ext cx="4321704" cy="3871518"/>
-          </a:xfrm>
-          <a:prstGeom prst="rect">
-            <a:avLst/>
-          </a:prstGeom>
-        </p:spPr>
-        <p:txBody>
-          <a:bodyPr vert="horz" lIns="91440" tIns="45720" rIns="91440" bIns="45720" rtlCol="0">
-            <a:normAutofit/>
-          </a:bodyPr>
-          <a:lstStyle>
-            <a:lvl1pPr marL="228600" indent="-228600" algn="l" defTabSz="914400" rtl="0" eaLnBrk="1" latinLnBrk="0" hangingPunct="1">
-              <a:lnSpc>
-                <a:spcPts val="1800"/>
-              </a:lnSpc>
-              <a:spcBef>
-                <a:spcPts val="1000"/>
-              </a:spcBef>
-              <a:spcAft>
-                <a:spcPts val="1000"/>
-              </a:spcAft>
-              <a:buFont typeface="Arial" panose="020B0604020202020204" pitchFamily="34" charset="0"/>
-              <a:buChar char="•"/>
-              <a:defRPr lang="en-US" sz="1200" kern="1200" smtClean="0">
-                <a:solidFill>
-                  <a:schemeClr val="tx1">
-                    <a:lumMod val="75000"/>
-                    <a:lumOff val="25000"/>
-                  </a:schemeClr>
-                </a:solidFill>
-                <a:latin typeface="+mn-lt"/>
-                <a:ea typeface="+mn-ea"/>
-                <a:cs typeface="+mn-cs"/>
-              </a:defRPr>
-            </a:lvl1pPr>
-            <a:lvl2pPr marL="685800" indent="-228600" algn="l" defTabSz="914400" rtl="0" eaLnBrk="1" latinLnBrk="0" hangingPunct="1">
-              <a:lnSpc>
-                <a:spcPts val="1800"/>
-              </a:lnSpc>
-              <a:spcBef>
-                <a:spcPts val="1000"/>
-              </a:spcBef>
-              <a:spcAft>
-                <a:spcPts val="1000"/>
-              </a:spcAft>
-              <a:buFont typeface="Arial" panose="020B0604020202020204" pitchFamily="34" charset="0"/>
-              <a:buChar char="•"/>
-              <a:defRPr lang="en-US" sz="1200" kern="1200" smtClean="0">
-                <a:solidFill>
-                  <a:schemeClr val="tx1">
-                    <a:lumMod val="75000"/>
-                    <a:lumOff val="25000"/>
-                  </a:schemeClr>
-                </a:solidFill>
-                <a:latin typeface="+mn-lt"/>
-                <a:ea typeface="+mn-ea"/>
-                <a:cs typeface="+mn-cs"/>
-              </a:defRPr>
-            </a:lvl2pPr>
-            <a:lvl3pPr marL="1143000" indent="-228600" algn="l" defTabSz="914400" rtl="0" eaLnBrk="1" latinLnBrk="0" hangingPunct="1">
-              <a:lnSpc>
-                <a:spcPts val="1800"/>
-              </a:lnSpc>
-              <a:spcBef>
-                <a:spcPts val="1000"/>
-              </a:spcBef>
-              <a:spcAft>
-                <a:spcPts val="1000"/>
-              </a:spcAft>
-              <a:buFont typeface="Arial" panose="020B0604020202020204" pitchFamily="34" charset="0"/>
-              <a:buChar char="•"/>
-              <a:defRPr lang="en-US" sz="1200" kern="1200" smtClean="0">
-                <a:solidFill>
-                  <a:schemeClr val="tx1">
-                    <a:lumMod val="75000"/>
-                    <a:lumOff val="25000"/>
-                  </a:schemeClr>
-                </a:solidFill>
-                <a:latin typeface="+mn-lt"/>
-                <a:ea typeface="+mn-ea"/>
-                <a:cs typeface="+mn-cs"/>
-              </a:defRPr>
-            </a:lvl3pPr>
-            <a:lvl4pPr marL="1600200" indent="-228600" algn="l" defTabSz="914400" rtl="0" eaLnBrk="1" latinLnBrk="0" hangingPunct="1">
-              <a:lnSpc>
-                <a:spcPts val="1800"/>
-              </a:lnSpc>
-              <a:spcBef>
-                <a:spcPts val="1000"/>
-              </a:spcBef>
-              <a:spcAft>
-                <a:spcPts val="1000"/>
-              </a:spcAft>
-              <a:buFont typeface="Arial" panose="020B0604020202020204" pitchFamily="34" charset="0"/>
-              <a:buChar char="•"/>
-              <a:defRPr lang="en-US" sz="1200" kern="1200" smtClean="0">
-                <a:solidFill>
-                  <a:schemeClr val="tx1">
-                    <a:lumMod val="75000"/>
-                    <a:lumOff val="25000"/>
-                  </a:schemeClr>
-                </a:solidFill>
-                <a:latin typeface="+mn-lt"/>
-                <a:ea typeface="+mn-ea"/>
-                <a:cs typeface="+mn-cs"/>
-              </a:defRPr>
-            </a:lvl4pPr>
-            <a:lvl5pPr marL="2057400" indent="-228600" algn="l" defTabSz="914400" rtl="0" eaLnBrk="1" latinLnBrk="0" hangingPunct="1">
-              <a:lnSpc>
-                <a:spcPts val="1800"/>
-              </a:lnSpc>
-              <a:spcBef>
-                <a:spcPts val="1000"/>
-              </a:spcBef>
-              <a:spcAft>
-                <a:spcPts val="1000"/>
-              </a:spcAft>
-              <a:buFont typeface="Arial" panose="020B0604020202020204" pitchFamily="34" charset="0"/>
-              <a:buChar char="•"/>
-              <a:defRPr lang="en-US" sz="1200" kern="1200">
-                <a:solidFill>
-                  <a:schemeClr val="tx1">
-                    <a:lumMod val="75000"/>
-                    <a:lumOff val="25000"/>
-                  </a:schemeClr>
-                </a:solidFill>
-                <a:latin typeface="+mn-lt"/>
-                <a:ea typeface="+mn-ea"/>
-                <a:cs typeface="+mn-cs"/>
-              </a:defRPr>
-            </a:lvl5pPr>
-            <a:lvl6pPr marL="2514600" indent="-228600" algn="l" defTabSz="914400" rtl="0" eaLnBrk="1" latinLnBrk="0" hangingPunct="1">
-              <a:lnSpc>
-                <a:spcPct val="90000"/>
-              </a:lnSpc>
-              <a:spcBef>
-                <a:spcPct val="30000"/>
-              </a:spcBef>
-              <a:buFont typeface="Arial" panose="020B0604020202020204" pitchFamily="34" charset="0"/>
-              <a:buChar char="•"/>
-              <a:defRPr sz="1800" kern="1200">
-                <a:solidFill>
-                  <a:schemeClr val="tx1"/>
-                </a:solidFill>
-                <a:latin typeface="+mn-lt"/>
-                <a:ea typeface="+mn-ea"/>
-                <a:cs typeface="+mn-cs"/>
-              </a:defRPr>
-            </a:lvl6pPr>
-            <a:lvl7pPr marL="2971800" indent="-228600" algn="l" defTabSz="914400" rtl="0" eaLnBrk="1" latinLnBrk="0" hangingPunct="1">
-              <a:lnSpc>
-                <a:spcPct val="90000"/>
-              </a:lnSpc>
-              <a:spcBef>
-                <a:spcPct val="30000"/>
-              </a:spcBef>
-              <a:buFont typeface="Arial" panose="020B0604020202020204" pitchFamily="34" charset="0"/>
-              <a:buChar char="•"/>
-              <a:defRPr sz="1800" kern="1200">
-                <a:solidFill>
-                  <a:schemeClr val="tx1"/>
-                </a:solidFill>
-                <a:latin typeface="+mn-lt"/>
-                <a:ea typeface="+mn-ea"/>
-                <a:cs typeface="+mn-cs"/>
-              </a:defRPr>
-            </a:lvl7pPr>
-            <a:lvl8pPr marL="3429000" indent="-228600" algn="l" defTabSz="914400" rtl="0" eaLnBrk="1" latinLnBrk="0" hangingPunct="1">
-              <a:lnSpc>
-                <a:spcPct val="90000"/>
-              </a:lnSpc>
-              <a:spcBef>
-                <a:spcPct val="30000"/>
-              </a:spcBef>
-              <a:buFont typeface="Arial" panose="020B0604020202020204" pitchFamily="34" charset="0"/>
-              <a:buChar char="•"/>
-              <a:defRPr sz="1800" kern="1200">
-                <a:solidFill>
-                  <a:schemeClr val="tx1"/>
-                </a:solidFill>
-                <a:latin typeface="+mn-lt"/>
-                <a:ea typeface="+mn-ea"/>
-                <a:cs typeface="+mn-cs"/>
-              </a:defRPr>
-            </a:lvl8pPr>
-            <a:lvl9pPr marL="3886200" indent="-228600" algn="l" defTabSz="914400" rtl="0" eaLnBrk="1" latinLnBrk="0" hangingPunct="1">
-              <a:lnSpc>
-                <a:spcPct val="90000"/>
-              </a:lnSpc>
-              <a:spcBef>
-                <a:spcPct val="30000"/>
-              </a:spcBef>
-              <a:buFont typeface="Arial" panose="020B0604020202020204" pitchFamily="34" charset="0"/>
-              <a:buChar char="•"/>
-              <a:defRPr sz="1800" kern="1200">
-                <a:solidFill>
-                  <a:schemeClr val="tx1"/>
-                </a:solidFill>
-                <a:latin typeface="+mn-lt"/>
-                <a:ea typeface="+mn-ea"/>
-                <a:cs typeface="+mn-cs"/>
-              </a:defRPr>
-            </a:lvl9pPr>
-          </a:lstStyle>
-          <a:p>
-            <a:pPr marL="0" lvl="0" indent="0" rtl="0">
-              <a:spcAft>
-                <a:spcPts val="600"/>
-              </a:spcAft>
-              <a:buNone/>
-              <a:defRPr/>
-            </a:pPr>
-            <a:endParaRPr lang="zh-CN" altLang="en-US" dirty="0">
-              <a:latin typeface="Microsoft YaHei UI" panose="020B0503020204020204" pitchFamily="34" charset="-122"/>
-              <a:ea typeface="Microsoft YaHei UI" panose="020B0503020204020204" pitchFamily="34" charset="-122"/>
-              <a:cs typeface="Segoe UI" panose="020B0502040204020203" pitchFamily="34" charset="0"/>
-            </a:endParaRPr>
-          </a:p>
-        </p:txBody>
-      </p:sp>
-      <p:sp>
-        <p:nvSpPr>
-          <p:cNvPr id="6" name="文本框 5">
-            <a:extLst>
-              <a:ext uri="{FF2B5EF4-FFF2-40B4-BE49-F238E27FC236}">
-                <a16:creationId xmlns:a16="http://schemas.microsoft.com/office/drawing/2014/main" id="{C2338F5D-E4F9-2B47-9149-58501040415A}"/>
-              </a:ext>
-            </a:extLst>
-          </p:cNvPr>
-          <p:cNvSpPr txBox="1"/>
-          <p:nvPr/>
-        </p:nvSpPr>
-        <p:spPr>
-          <a:xfrm>
-            <a:off x="702734" y="1703610"/>
-            <a:ext cx="5837214" cy="2308324"/>
+            <a:off x="868680" y="1325880"/>
+            <a:ext cx="10332720" cy="4480560"/>
           </a:xfrm>
           <a:prstGeom prst="rect">
             <a:avLst/>
@@ -4081,44 +3837,36 @@
           <a:lstStyle/>
           <a:p>
             <a:r>
-              <a:rPr lang="zh-CN" altLang="en-US" dirty="0"/>
-              <a:t>延音踏板对于音乐的表现力、共鸣效果以及连贯演奏至关重要。</a:t>
-            </a:r>
-            <a:endParaRPr lang="en-US" altLang="zh-CN" dirty="0"/>
-          </a:p>
-          <a:p>
-            <a:endParaRPr lang="en-US" altLang="zh-CN" dirty="0"/>
-          </a:p>
-          <a:p>
-            <a:r>
-              <a:rPr lang="zh-CN" altLang="en-US" dirty="0"/>
-              <a:t>许多 </a:t>
-            </a:r>
-            <a:r>
-              <a:rPr lang="en-US" altLang="zh-CN" dirty="0"/>
-              <a:t>MIDI </a:t>
-            </a:r>
-            <a:r>
-              <a:rPr lang="zh-CN" altLang="en-US" dirty="0"/>
-              <a:t>数据集缺乏真实的踏板信息，从而降低了表现力。</a:t>
-            </a:r>
-            <a:endParaRPr lang="en-US" altLang="zh-CN" dirty="0"/>
-          </a:p>
-          <a:p>
-            <a:endParaRPr lang="en-US" altLang="zh-CN" dirty="0"/>
-          </a:p>
-          <a:p>
-            <a:r>
-              <a:rPr lang="zh-CN" altLang="en-US" dirty="0"/>
-              <a:t>项目问题：我们如何通过精确模拟延音踏板的使用情况来生成听起来更像真实人类演奏的 </a:t>
-            </a:r>
-            <a:r>
-              <a:rPr lang="en-US" altLang="zh-CN" dirty="0"/>
-              <a:t>MIDI </a:t>
-            </a:r>
-            <a:r>
-              <a:rPr lang="zh-CN" altLang="en-US" dirty="0"/>
-              <a:t>作品？</a:t>
+              <a:rPr sz="2400"/>
+              <a:t>• 从“技术研究介绍”切换为“工作能力展示”</a:t>
+            </a:r>
+          </a:p>
+          <a:p>
+            <a:pPr>
+              <a:spcBef>
+                <a:spcPts val="0"/>
+              </a:spcBef>
+              <a:spcAft>
+                <a:spcPts val="800"/>
+              </a:spcAft>
+            </a:pPr>
+            <a:r>
+              <a:rPr sz="2400"/>
+              <a:t>• 聚焦项目管理、项目规划、跨团队推进与交付结果</a:t>
+            </a:r>
+          </a:p>
+          <a:p>
+            <a:pPr>
+              <a:spcBef>
+                <a:spcPts val="0"/>
+              </a:spcBef>
+              <a:spcAft>
+                <a:spcPts val="800"/>
+              </a:spcAft>
+            </a:pPr>
+            <a:r>
+              <a:rPr sz="2400"/>
+              <a:t>• 当前先确认页面结构，后续逐页补充具体项目内容</a:t>
             </a:r>
           </a:p>
         </p:txBody>
@@ -4167,36 +3915,6 @@
           <a:chExt cx="0" cy="0"/>
         </a:xfrm>
       </p:grpSpPr>
-      <p:pic>
-        <p:nvPicPr>
-          <p:cNvPr id="5" name="图片 4">
-            <a:extLst>
-              <a:ext uri="{FF2B5EF4-FFF2-40B4-BE49-F238E27FC236}">
-                <a16:creationId xmlns:a16="http://schemas.microsoft.com/office/drawing/2014/main" id="{48604011-06F3-1427-D11F-E2354C496EC5}"/>
-              </a:ext>
-            </a:extLst>
-          </p:cNvPr>
-          <p:cNvPicPr>
-            <a:picLocks noChangeAspect="1"/>
-          </p:cNvPicPr>
-          <p:nvPr/>
-        </p:nvPicPr>
-        <p:blipFill>
-          <a:blip r:embed="rId3"/>
-          <a:stretch>
-            <a:fillRect/>
-          </a:stretch>
-        </p:blipFill>
-        <p:spPr>
-          <a:xfrm>
-            <a:off x="669826" y="3675656"/>
-            <a:ext cx="7753351" cy="2644481"/>
-          </a:xfrm>
-          <a:prstGeom prst="rect">
-            <a:avLst/>
-          </a:prstGeom>
-        </p:spPr>
-      </p:pic>
       <p:sp>
         <p:nvSpPr>
           <p:cNvPr id="3" name="标题 2">
@@ -4215,32 +3933,26 @@
         </p:nvSpPr>
         <p:spPr/>
         <p:txBody>
-          <a:bodyPr/>
+          <a:bodyPr wrap="square"/>
           <a:lstStyle/>
           <a:p>
             <a:r>
-              <a:rPr lang="zh-CN" altLang="en-US" dirty="0"/>
-              <a:t>数据集与表示形式</a:t>
-            </a:r>
-          </a:p>
-        </p:txBody>
-      </p:sp>
-      <p:sp>
-        <p:nvSpPr>
-          <p:cNvPr id="6" name="文本框 5">
-            <a:extLst>
-              <a:ext uri="{FF2B5EF4-FFF2-40B4-BE49-F238E27FC236}">
-                <a16:creationId xmlns:a16="http://schemas.microsoft.com/office/drawing/2014/main" id="{ADADE8DA-E872-6FF2-BC6F-BE47BAA95FBC}"/>
-              </a:ext>
-            </a:extLst>
-          </p:cNvPr>
+              <a:rPr sz="2800" b="1"/>
+              <a:t>项目管理能力总览</a:t>
+            </a:r>
+          </a:p>
+        </p:txBody>
+      </p:sp>
+      <p:sp>
+        <p:nvSpPr>
+          <p:cNvPr id="4" name="TextBox 3"/>
           <p:cNvSpPr txBox="1"/>
           <p:nvPr/>
         </p:nvSpPr>
         <p:spPr>
           <a:xfrm>
-            <a:off x="669826" y="1267512"/>
-            <a:ext cx="9573866" cy="2308324"/>
+            <a:off x="868680" y="1325880"/>
+            <a:ext cx="10332720" cy="4480560"/>
           </a:xfrm>
           <a:prstGeom prst="rect">
             <a:avLst/>
@@ -4254,57 +3966,51 @@
           <a:lstStyle/>
           <a:p>
             <a:r>
-              <a:rPr lang="it-IT" altLang="zh-CN" dirty="0"/>
-              <a:t>MAESTRO </a:t>
-            </a:r>
-            <a:r>
-              <a:rPr lang="zh-CN" altLang="en-US" dirty="0"/>
-              <a:t>数据集</a:t>
-            </a:r>
-            <a:br>
-              <a:rPr lang="it-IT" altLang="zh-CN" dirty="0"/>
-            </a:br>
-            <a:br>
-              <a:rPr lang="it-IT" altLang="zh-CN" dirty="0"/>
-            </a:br>
-            <a:r>
-              <a:rPr lang="zh-CN" altLang="en-US" b="1" dirty="0"/>
-              <a:t>一个包含超过 </a:t>
-            </a:r>
-            <a:r>
-              <a:rPr lang="en-US" altLang="zh-CN" b="1" dirty="0"/>
-              <a:t>200 </a:t>
-            </a:r>
-            <a:r>
-              <a:rPr lang="zh-CN" altLang="en-US" b="1" dirty="0"/>
-              <a:t>小时高超演奏的大型钢琴数据集。由谷歌马格纳团队与国际钢琴电子竞赛合作发布。</a:t>
-            </a:r>
-            <a:endParaRPr lang="en-US" altLang="zh-CN" b="1" dirty="0"/>
-          </a:p>
-          <a:p>
-            <a:r>
-              <a:rPr lang="zh-CN" altLang="en-US" b="1" dirty="0"/>
-              <a:t>提供了与时间精度极高的音频和 </a:t>
-            </a:r>
-            <a:r>
-              <a:rPr lang="en-US" altLang="zh-CN" b="1" dirty="0"/>
-              <a:t>MIDI </a:t>
-            </a:r>
-            <a:r>
-              <a:rPr lang="zh-CN" altLang="en-US" b="1" dirty="0"/>
-              <a:t>录音相匹配的文件。</a:t>
-            </a:r>
-            <a:endParaRPr lang="en-US" altLang="zh-CN" b="1" dirty="0"/>
-          </a:p>
-          <a:p>
-            <a:r>
-              <a:rPr lang="zh-CN" altLang="en-US" b="1" dirty="0"/>
-              <a:t>广泛用于音乐生成、转录和富有表现力的演奏模型构建。包含详细的延音踏板信息，使其非常适合研究富有表现力演奏中的踏板使用情况。</a:t>
-            </a:r>
-            <a:endParaRPr lang="it-IT" altLang="zh-CN" dirty="0"/>
-          </a:p>
-          <a:p>
-            <a:endParaRPr lang="it-IT" altLang="zh-CN" dirty="0"/>
+              <a:rPr sz="2400"/>
+              <a:t>• 项目立项与目标定义</a:t>
+            </a:r>
+          </a:p>
+          <a:p>
+            <a:pPr>
+              <a:spcBef>
+                <a:spcPts val="0"/>
+              </a:spcBef>
+              <a:spcAft>
+                <a:spcPts val="800"/>
+              </a:spcAft>
+            </a:pPr>
+            <a:r>
+              <a:rPr sz="2400"/>
+              <a:t>• 范围拆解与优先级管理</a:t>
+            </a:r>
+          </a:p>
+          <a:p>
+            <a:pPr>
+              <a:spcBef>
+                <a:spcPts val="0"/>
+              </a:spcBef>
+              <a:spcAft>
+                <a:spcPts val="800"/>
+              </a:spcAft>
+            </a:pPr>
+            <a:r>
+              <a:rPr sz="2400"/>
+              <a:t>• 计划制定、里程碑设计与进度控制</a:t>
+            </a:r>
+          </a:p>
+          <a:p>
+            <a:pPr>
+              <a:spcBef>
+                <a:spcPts val="0"/>
+              </a:spcBef>
+              <a:spcAft>
+                <a:spcPts val="800"/>
+              </a:spcAft>
+            </a:pPr>
+            <a:r>
+              <a:rPr sz="2400"/>
+              <a:t>• 风险识别、资源协调、沟通与复盘</a:t>
+            </a:r>
           </a:p>
         </p:txBody>
       </p:sp>
@@ -4364,170 +4070,87 @@
         </p:nvSpPr>
         <p:spPr/>
         <p:txBody>
-          <a:bodyPr/>
+          <a:bodyPr wrap="square"/>
           <a:lstStyle/>
           <a:p>
             <a:r>
-              <a:rPr lang="en-US" altLang="zh-CN" dirty="0"/>
-              <a:t>Mask</a:t>
-            </a:r>
-            <a:r>
-              <a:rPr lang="zh-CN" altLang="en-US" dirty="0"/>
-              <a:t>预测与段落分割</a:t>
-            </a:r>
-          </a:p>
-        </p:txBody>
-      </p:sp>
-      <p:pic>
-        <p:nvPicPr>
-          <p:cNvPr id="14" name="图片 13">
-            <a:extLst>
-              <a:ext uri="{FF2B5EF4-FFF2-40B4-BE49-F238E27FC236}">
-                <a16:creationId xmlns:a16="http://schemas.microsoft.com/office/drawing/2014/main" id="{3B4612A8-4B85-F6F2-6A65-7B9896AAFF81}"/>
-              </a:ext>
-            </a:extLst>
-          </p:cNvPr>
-          <p:cNvPicPr>
-            <a:picLocks noChangeAspect="1"/>
-          </p:cNvPicPr>
+              <a:rPr sz="2800" b="1"/>
+              <a:t>整套PPT建议结构</a:t>
+            </a:r>
+          </a:p>
+        </p:txBody>
+      </p:sp>
+      <p:sp>
+        <p:nvSpPr>
+          <p:cNvPr id="4" name="TextBox 3"/>
+          <p:cNvSpPr txBox="1"/>
           <p:nvPr/>
-        </p:nvPicPr>
-        <p:blipFill>
-          <a:blip r:embed="rId3"/>
-          <a:stretch>
-            <a:fillRect/>
-          </a:stretch>
-        </p:blipFill>
+        </p:nvSpPr>
         <p:spPr>
           <a:xfrm>
-            <a:off x="3198768" y="1452437"/>
-            <a:ext cx="4074798" cy="532293"/>
+            <a:off x="868680" y="1325880"/>
+            <a:ext cx="10332720" cy="4480560"/>
           </a:xfrm>
           <a:prstGeom prst="rect">
             <a:avLst/>
           </a:prstGeom>
+          <a:noFill/>
         </p:spPr>
-      </p:pic>
-      <p:pic>
-        <p:nvPicPr>
-          <p:cNvPr id="16" name="图片 15">
-            <a:extLst>
-              <a:ext uri="{FF2B5EF4-FFF2-40B4-BE49-F238E27FC236}">
-                <a16:creationId xmlns:a16="http://schemas.microsoft.com/office/drawing/2014/main" id="{18BB53B0-69D7-39A0-0CA6-95A1C6361E95}"/>
-              </a:ext>
-            </a:extLst>
-          </p:cNvPr>
-          <p:cNvPicPr>
-            <a:picLocks noChangeAspect="1"/>
-          </p:cNvPicPr>
-          <p:nvPr/>
-        </p:nvPicPr>
-        <p:blipFill>
-          <a:blip r:embed="rId4"/>
-          <a:stretch>
-            <a:fillRect/>
-          </a:stretch>
-        </p:blipFill>
-        <p:spPr>
-          <a:xfrm>
-            <a:off x="682962" y="2483019"/>
-            <a:ext cx="9646900" cy="3926925"/>
-          </a:xfrm>
-          <a:prstGeom prst="rect">
-            <a:avLst/>
-          </a:prstGeom>
-        </p:spPr>
-      </p:pic>
-      <p:pic>
-        <p:nvPicPr>
-          <p:cNvPr id="26" name="图片 25">
-            <a:extLst>
-              <a:ext uri="{FF2B5EF4-FFF2-40B4-BE49-F238E27FC236}">
-                <a16:creationId xmlns:a16="http://schemas.microsoft.com/office/drawing/2014/main" id="{F00FFB2D-A4DA-1C82-1DD9-FF532581D4D5}"/>
-              </a:ext>
-            </a:extLst>
-          </p:cNvPr>
-          <p:cNvPicPr>
-            <a:picLocks noChangeAspect="1"/>
-          </p:cNvPicPr>
-          <p:nvPr/>
-        </p:nvPicPr>
-        <p:blipFill>
-          <a:blip r:embed="rId5"/>
-          <a:stretch>
-            <a:fillRect/>
-          </a:stretch>
-        </p:blipFill>
-        <p:spPr>
-          <a:xfrm>
-            <a:off x="682962" y="2687754"/>
-            <a:ext cx="256969" cy="256969"/>
-          </a:xfrm>
-          <a:prstGeom prst="rect">
-            <a:avLst/>
-          </a:prstGeom>
-        </p:spPr>
-      </p:pic>
-      <p:pic>
-        <p:nvPicPr>
-          <p:cNvPr id="28" name="图片 27">
-            <a:extLst>
-              <a:ext uri="{FF2B5EF4-FFF2-40B4-BE49-F238E27FC236}">
-                <a16:creationId xmlns:a16="http://schemas.microsoft.com/office/drawing/2014/main" id="{891CDE75-FDAC-DE3D-C8E8-AA4E16122CEA}"/>
-              </a:ext>
-            </a:extLst>
-          </p:cNvPr>
-          <p:cNvPicPr>
-            <a:picLocks noChangeAspect="1"/>
-          </p:cNvPicPr>
-          <p:nvPr/>
-        </p:nvPicPr>
-        <p:blipFill>
-          <a:blip r:embed="rId6"/>
-          <a:stretch>
-            <a:fillRect/>
-          </a:stretch>
-        </p:blipFill>
-        <p:spPr>
-          <a:xfrm>
-            <a:off x="425751" y="3090039"/>
-            <a:ext cx="523116" cy="229437"/>
-          </a:xfrm>
-          <a:prstGeom prst="rect">
-            <a:avLst/>
-          </a:prstGeom>
-        </p:spPr>
-      </p:pic>
-      <p:pic>
-        <p:nvPicPr>
-          <p:cNvPr id="41" name="图片 40">
-            <a:extLst>
-              <a:ext uri="{FF2B5EF4-FFF2-40B4-BE49-F238E27FC236}">
-                <a16:creationId xmlns:a16="http://schemas.microsoft.com/office/drawing/2014/main" id="{CE02ABA9-09E8-31EB-A58C-72A800BAB542}"/>
-              </a:ext>
-            </a:extLst>
-          </p:cNvPr>
-          <p:cNvPicPr>
-            <a:picLocks noChangeAspect="1"/>
-          </p:cNvPicPr>
-          <p:nvPr/>
-        </p:nvPicPr>
-        <p:blipFill>
-          <a:blip r:embed="rId7"/>
-          <a:stretch>
-            <a:fillRect/>
-          </a:stretch>
-        </p:blipFill>
-        <p:spPr>
-          <a:xfrm>
-            <a:off x="387646" y="3826597"/>
-            <a:ext cx="541471" cy="238615"/>
-          </a:xfrm>
-          <a:prstGeom prst="rect">
-            <a:avLst/>
-          </a:prstGeom>
-        </p:spPr>
-      </p:pic>
+        <p:txBody>
+          <a:bodyPr wrap="square">
+            <a:spAutoFit/>
+          </a:bodyPr>
+          <a:lstStyle/>
+          <a:p>
+            <a:r>
+              <a:rPr sz="2400"/>
+              <a:t>• 个人角色定位：我负责什么、解决什么问题</a:t>
+            </a:r>
+          </a:p>
+          <a:p>
+            <a:pPr>
+              <a:spcBef>
+                <a:spcPts val="0"/>
+              </a:spcBef>
+              <a:spcAft>
+                <a:spcPts val="800"/>
+              </a:spcAft>
+            </a:pPr>
+            <a:r>
+              <a:rPr sz="2400"/>
+              <a:t>• 方法论部分：如何规划、推进、纠偏</a:t>
+            </a:r>
+          </a:p>
+          <a:p>
+            <a:pPr>
+              <a:spcBef>
+                <a:spcPts val="0"/>
+              </a:spcBef>
+              <a:spcAft>
+                <a:spcPts val="800"/>
+              </a:spcAft>
+            </a:pPr>
+            <a:r>
+              <a:rPr sz="2400"/>
+              <a:t>• 案例部分：选 1~2 个代表项目完整展开</a:t>
+            </a:r>
+          </a:p>
+          <a:p>
+            <a:pPr>
+              <a:spcBef>
+                <a:spcPts val="0"/>
+              </a:spcBef>
+              <a:spcAft>
+                <a:spcPts val="800"/>
+              </a:spcAft>
+            </a:pPr>
+            <a:r>
+              <a:rPr sz="2400"/>
+              <a:t>• 结果沉淀：交付成效、经验总结、方法复用</a:t>
+            </a:r>
+          </a:p>
+        </p:txBody>
+      </p:sp>
     </p:spTree>
     <p:extLst>
       <p:ext uri="{BB962C8B-B14F-4D97-AF65-F5344CB8AC3E}">
@@ -4572,36 +4195,6 @@
           <a:chExt cx="0" cy="0"/>
         </a:xfrm>
       </p:grpSpPr>
-      <p:pic>
-        <p:nvPicPr>
-          <p:cNvPr id="7" name="图片 6">
-            <a:extLst>
-              <a:ext uri="{FF2B5EF4-FFF2-40B4-BE49-F238E27FC236}">
-                <a16:creationId xmlns:a16="http://schemas.microsoft.com/office/drawing/2014/main" id="{925B1B09-FF72-E35D-EBDF-837000D81A7E}"/>
-              </a:ext>
-            </a:extLst>
-          </p:cNvPr>
-          <p:cNvPicPr>
-            <a:picLocks noChangeAspect="1"/>
-          </p:cNvPicPr>
-          <p:nvPr/>
-        </p:nvPicPr>
-        <p:blipFill>
-          <a:blip r:embed="rId3"/>
-          <a:stretch>
-            <a:fillRect/>
-          </a:stretch>
-        </p:blipFill>
-        <p:spPr>
-          <a:xfrm>
-            <a:off x="937031" y="1683891"/>
-            <a:ext cx="5288737" cy="4459528"/>
-          </a:xfrm>
-          <a:prstGeom prst="rect">
-            <a:avLst/>
-          </a:prstGeom>
-        </p:spPr>
-      </p:pic>
       <p:sp>
         <p:nvSpPr>
           <p:cNvPr id="3" name="标题 2">
@@ -4620,32 +4213,26 @@
         </p:nvSpPr>
         <p:spPr/>
         <p:txBody>
-          <a:bodyPr/>
+          <a:bodyPr wrap="square"/>
           <a:lstStyle/>
           <a:p>
             <a:r>
-              <a:rPr lang="zh-CN" altLang="en-US" dirty="0"/>
-              <a:t>模型结构</a:t>
-            </a:r>
-          </a:p>
-        </p:txBody>
-      </p:sp>
-      <p:sp>
-        <p:nvSpPr>
-          <p:cNvPr id="2" name="文本框 1">
-            <a:extLst>
-              <a:ext uri="{FF2B5EF4-FFF2-40B4-BE49-F238E27FC236}">
-                <a16:creationId xmlns:a16="http://schemas.microsoft.com/office/drawing/2014/main" id="{B8ED8304-B9DB-BD09-EA42-E0E0BC59F2D4}"/>
-              </a:ext>
-            </a:extLst>
-          </p:cNvPr>
+              <a:rPr sz="2800" b="1"/>
+              <a:t>项目规划能力展示框架</a:t>
+            </a:r>
+          </a:p>
+        </p:txBody>
+      </p:sp>
+      <p:sp>
+        <p:nvSpPr>
+          <p:cNvPr id="4" name="TextBox 3"/>
           <p:cNvSpPr txBox="1"/>
           <p:nvPr/>
         </p:nvSpPr>
         <p:spPr>
           <a:xfrm>
-            <a:off x="7211291" y="2400300"/>
-            <a:ext cx="3855027" cy="2031325"/>
+            <a:off x="868680" y="1325880"/>
+            <a:ext cx="10332720" cy="4480560"/>
           </a:xfrm>
           <a:prstGeom prst="rect">
             <a:avLst/>
@@ -4653,44 +4240,56 @@
           <a:noFill/>
         </p:spPr>
         <p:txBody>
-          <a:bodyPr wrap="square" rtlCol="0">
+          <a:bodyPr wrap="square">
             <a:spAutoFit/>
           </a:bodyPr>
           <a:lstStyle/>
           <a:p>
             <a:r>
-              <a:rPr lang="zh-CN" altLang="en-US" dirty="0"/>
-              <a:t>部分重建</a:t>
-            </a:r>
-            <a:br>
-              <a:rPr lang="en-US" altLang="zh-CN" dirty="0"/>
-            </a:br>
-            <a:br>
-              <a:rPr lang="en-US" altLang="zh-CN" dirty="0"/>
-            </a:br>
-            <a:r>
-              <a:rPr lang="zh-CN" altLang="en-US" dirty="0"/>
-              <a:t>输入保留按键信息和踏板起点</a:t>
-            </a:r>
-            <a:br>
-              <a:rPr lang="en-US" altLang="zh-CN" dirty="0"/>
-            </a:br>
-            <a:br>
-              <a:rPr lang="en-US" altLang="zh-CN" dirty="0"/>
-            </a:br>
-            <a:r>
-              <a:rPr lang="zh-CN" altLang="en-US" dirty="0"/>
-              <a:t>全部重建</a:t>
-            </a:r>
-            <a:br>
-              <a:rPr lang="en-US" altLang="zh-CN" dirty="0"/>
-            </a:br>
-            <a:br>
-              <a:rPr lang="en-US" altLang="zh-CN" dirty="0"/>
-            </a:br>
-            <a:r>
-              <a:rPr lang="zh-CN" altLang="en-US" dirty="0"/>
-              <a:t>输入只包含按键信息</a:t>
+              <a:rPr sz="2400"/>
+              <a:t>• 目标拆解：业务目标 → 项目目标 → 阶段成果</a:t>
+            </a:r>
+          </a:p>
+          <a:p>
+            <a:pPr>
+              <a:spcBef>
+                <a:spcPts val="0"/>
+              </a:spcBef>
+              <a:spcAft>
+                <a:spcPts val="800"/>
+              </a:spcAft>
+            </a:pPr>
+            <a:r>
+              <a:rPr sz="2400"/>
+              <a:t>• 任务分解：WBS、优先级、责任人、依赖关系</a:t>
+            </a:r>
+          </a:p>
+          <a:p>
+            <a:pPr>
+              <a:spcBef>
+                <a:spcPts val="0"/>
+              </a:spcBef>
+              <a:spcAft>
+                <a:spcPts val="800"/>
+              </a:spcAft>
+            </a:pPr>
+            <a:r>
+              <a:rPr sz="2400"/>
+              <a:t>• 排期设计：关键路径、缓冲时间、里程碑检查点</a:t>
+            </a:r>
+          </a:p>
+          <a:p>
+            <a:pPr>
+              <a:spcBef>
+                <a:spcPts val="0"/>
+              </a:spcBef>
+              <a:spcAft>
+                <a:spcPts val="800"/>
+              </a:spcAft>
+            </a:pPr>
+            <a:r>
+              <a:rPr sz="2400"/>
+              <a:t>• 资源安排：人力、时间、协作接口与风险预留</a:t>
             </a:r>
           </a:p>
         </p:txBody>
@@ -4757,46 +4356,73 @@
         </p:nvSpPr>
         <p:spPr/>
         <p:txBody>
-          <a:bodyPr/>
+          <a:bodyPr wrap="square"/>
           <a:lstStyle/>
           <a:p>
             <a:r>
-              <a:rPr lang="zh-CN" altLang="en-US" dirty="0"/>
-              <a:t>预测结果样例</a:t>
-            </a:r>
-          </a:p>
-        </p:txBody>
-      </p:sp>
-      <p:pic>
-        <p:nvPicPr>
-          <p:cNvPr id="4" name="图片 3">
-            <a:extLst>
-              <a:ext uri="{FF2B5EF4-FFF2-40B4-BE49-F238E27FC236}">
-                <a16:creationId xmlns:a16="http://schemas.microsoft.com/office/drawing/2014/main" id="{EBF54523-AFFF-DD2C-293A-FDDA419E9F50}"/>
-              </a:ext>
-            </a:extLst>
-          </p:cNvPr>
-          <p:cNvPicPr>
-            <a:picLocks noChangeAspect="1"/>
-          </p:cNvPicPr>
+              <a:rPr sz="2800" b="1"/>
+              <a:t>项目启动与需求澄清</a:t>
+            </a:r>
+          </a:p>
+        </p:txBody>
+      </p:sp>
+      <p:sp>
+        <p:nvSpPr>
+          <p:cNvPr id="4" name="TextBox 3"/>
+          <p:cNvSpPr txBox="1"/>
           <p:nvPr/>
-        </p:nvPicPr>
-        <p:blipFill>
-          <a:blip r:embed="rId3"/>
-          <a:stretch>
-            <a:fillRect/>
-          </a:stretch>
-        </p:blipFill>
+        </p:nvSpPr>
         <p:spPr>
           <a:xfrm>
-            <a:off x="521207" y="1464273"/>
-            <a:ext cx="8222743" cy="4276273"/>
+            <a:off x="868680" y="1325880"/>
+            <a:ext cx="10332720" cy="4480560"/>
           </a:xfrm>
           <a:prstGeom prst="rect">
             <a:avLst/>
           </a:prstGeom>
+          <a:noFill/>
         </p:spPr>
-      </p:pic>
+        <p:txBody>
+          <a:bodyPr wrap="square">
+            <a:spAutoFit/>
+          </a:bodyPr>
+          <a:lstStyle/>
+          <a:p>
+            <a:r>
+              <a:rPr sz="2400"/>
+              <a:t>• 说明项目背景、目标、约束与成功标准</a:t>
+            </a:r>
+          </a:p>
+          <a:p>
+            <a:pPr>
+              <a:spcBef>
+                <a:spcPts val="0"/>
+              </a:spcBef>
+              <a:spcAft>
+                <a:spcPts val="800"/>
+              </a:spcAft>
+            </a:pPr>
+            <a:r>
+              <a:rPr sz="2400"/>
+              <a:t>• 对齐关键干系人诉求，明确边界与优先级</a:t>
+            </a:r>
+          </a:p>
+          <a:p>
+            <a:pPr>
+              <a:spcBef>
+                <a:spcPts val="0"/>
+              </a:spcBef>
+              <a:spcAft>
+                <a:spcPts val="800"/>
+              </a:spcAft>
+            </a:pPr>
+            <a:r>
+              <a:rPr sz="2400"/>
+              <a:t>• 输出项目范围、版本节奏和阶段性交付物</a:t>
+            </a:r>
+          </a:p>
+        </p:txBody>
+      </p:sp>
     </p:spTree>
     <p:extLst>
       <p:ext uri="{BB962C8B-B14F-4D97-AF65-F5344CB8AC3E}">
@@ -4837,43 +4463,64 @@
       </p:grpSpPr>
       <p:sp>
         <p:nvSpPr>
-          <p:cNvPr id="4" name="矩形 3">
-            <a:extLst>
-              <a:ext uri="{FF2B5EF4-FFF2-40B4-BE49-F238E27FC236}">
-                <a16:creationId xmlns:a16="http://schemas.microsoft.com/office/drawing/2014/main" id="{2FC01135-6D74-F0C3-AB97-1C8132E70E8D}"/>
-              </a:ext>
-            </a:extLst>
-          </p:cNvPr>
-          <p:cNvSpPr/>
+          <p:cNvPr id="2" name="TextBox 1"/>
+          <p:cNvSpPr txBox="1"/>
           <p:nvPr/>
         </p:nvSpPr>
         <p:spPr>
           <a:xfrm>
-            <a:off x="1517833" y="2840879"/>
-            <a:ext cx="1163187" cy="3174558"/>
+            <a:off x="685800" y="274320"/>
+            <a:ext cx="5943600" cy="548640"/>
           </a:xfrm>
           <a:prstGeom prst="rect">
             <a:avLst/>
           </a:prstGeom>
+          <a:noFill/>
+        </p:spPr>
+        <p:txBody>
+          <a:bodyPr wrap="none">
+            <a:spAutoFit/>
+          </a:bodyPr>
+          <a:lstStyle/>
+          <a:p>
+            <a:r>
+              <a:rPr sz="2800" b="1"/>
+              <a:t>项目推进节奏与关键里程碑</a:t>
+            </a:r>
+          </a:p>
+        </p:txBody>
+      </p:sp>
+      <p:sp>
+        <p:nvSpPr>
+          <p:cNvPr id="3" name="Rounded Rectangle 2"/>
+          <p:cNvSpPr/>
+          <p:nvPr/>
+        </p:nvSpPr>
+        <p:spPr>
+          <a:xfrm>
+            <a:off x="822960" y="1828800"/>
+            <a:ext cx="1645920" cy="1920240"/>
+          </a:xfrm>
+          <a:prstGeom prst="roundRect">
+            <a:avLst/>
+          </a:prstGeom>
           <a:solidFill>
-            <a:srgbClr val="00B050">
-              <a:alpha val="50000"/>
-            </a:srgbClr>
+            <a:srgbClr val="3498DB"/>
           </a:solidFill>
           <a:ln>
-            <a:noFill/>
+            <a:solidFill>
+              <a:srgbClr val="3498DB"/>
+            </a:solidFill>
           </a:ln>
         </p:spPr>
         <p:style>
-          <a:lnRef idx="2">
-            <a:schemeClr val="accent1">
-              <a:shade val="15000"/>
-            </a:schemeClr>
+          <a:lnRef idx="1">
+            <a:schemeClr val="accent1"/>
           </a:lnRef>
-          <a:fillRef idx="1">
+          <a:fillRef idx="3">
             <a:schemeClr val="accent1"/>
           </a:fillRef>
-          <a:effectRef idx="0">
+          <a:effectRef idx="2">
             <a:schemeClr val="accent1"/>
           </a:effectRef>
           <a:fontRef idx="minor">
@@ -4885,53 +4532,58 @@
           <a:lstStyle/>
           <a:p>
             <a:pPr algn="ctr"/>
-            <a:endParaRPr lang="zh-CN" altLang="en-US">
-              <a:solidFill>
-                <a:srgbClr val="92D050"/>
-              </a:solidFill>
-            </a:endParaRPr>
-          </a:p>
-        </p:txBody>
-      </p:sp>
-      <p:sp>
-        <p:nvSpPr>
-          <p:cNvPr id="5" name="矩形 4">
-            <a:extLst>
-              <a:ext uri="{FF2B5EF4-FFF2-40B4-BE49-F238E27FC236}">
-                <a16:creationId xmlns:a16="http://schemas.microsoft.com/office/drawing/2014/main" id="{78E2FA81-080B-F62F-5904-2BCDC3BBFD0D}"/>
-              </a:ext>
-            </a:extLst>
-          </p:cNvPr>
+            <a:r>
+              <a:rPr sz="1600" b="1">
+                <a:solidFill>
+                  <a:srgbClr val="FFFFFF"/>
+                </a:solidFill>
+              </a:rPr>
+              <a:t>第1周</a:t>
+            </a:r>
+          </a:p>
+          <a:p>
+            <a:r>
+              <a:rPr sz="1800" b="1">
+                <a:solidFill>
+                  <a:srgbClr val="FFFFFF"/>
+                </a:solidFill>
+              </a:rPr>
+              <a:t>项目启动</a:t>
+            </a:r>
+          </a:p>
+        </p:txBody>
+      </p:sp>
+      <p:sp>
+        <p:nvSpPr>
+          <p:cNvPr id="4" name="Rounded Rectangle 3"/>
           <p:cNvSpPr/>
           <p:nvPr/>
         </p:nvSpPr>
         <p:spPr>
           <a:xfrm>
-            <a:off x="2681020" y="2840879"/>
-            <a:ext cx="1163185" cy="3174558"/>
+            <a:off x="2743200" y="1828800"/>
+            <a:ext cx="1645920" cy="1920240"/>
           </a:xfrm>
-          <a:prstGeom prst="rect">
+          <a:prstGeom prst="roundRect">
             <a:avLst/>
           </a:prstGeom>
           <a:solidFill>
-            <a:srgbClr val="FFFF00">
-              <a:alpha val="50000"/>
-            </a:srgbClr>
+            <a:srgbClr val="2ECC71"/>
           </a:solidFill>
           <a:ln>
-            <a:noFill/>
+            <a:solidFill>
+              <a:srgbClr val="2ECC71"/>
+            </a:solidFill>
           </a:ln>
         </p:spPr>
         <p:style>
-          <a:lnRef idx="2">
-            <a:schemeClr val="accent1">
-              <a:shade val="15000"/>
-            </a:schemeClr>
+          <a:lnRef idx="1">
+            <a:schemeClr val="accent1"/>
           </a:lnRef>
-          <a:fillRef idx="1">
+          <a:fillRef idx="3">
             <a:schemeClr val="accent1"/>
           </a:fillRef>
-          <a:effectRef idx="0">
+          <a:effectRef idx="2">
             <a:schemeClr val="accent1"/>
           </a:effectRef>
           <a:fontRef idx="minor">
@@ -4943,53 +4595,58 @@
           <a:lstStyle/>
           <a:p>
             <a:pPr algn="ctr"/>
-            <a:endParaRPr lang="zh-CN" altLang="en-US" dirty="0">
-              <a:solidFill>
-                <a:srgbClr val="92D050"/>
-              </a:solidFill>
-            </a:endParaRPr>
-          </a:p>
-        </p:txBody>
-      </p:sp>
-      <p:sp>
-        <p:nvSpPr>
-          <p:cNvPr id="8" name="矩形 7">
-            <a:extLst>
-              <a:ext uri="{FF2B5EF4-FFF2-40B4-BE49-F238E27FC236}">
-                <a16:creationId xmlns:a16="http://schemas.microsoft.com/office/drawing/2014/main" id="{2FA90B19-1567-F1B5-2D13-E2712FAAD148}"/>
-              </a:ext>
-            </a:extLst>
-          </p:cNvPr>
+            <a:r>
+              <a:rPr sz="1600" b="1">
+                <a:solidFill>
+                  <a:srgbClr val="FFFFFF"/>
+                </a:solidFill>
+              </a:rPr>
+              <a:t>第2周</a:t>
+            </a:r>
+          </a:p>
+          <a:p>
+            <a:r>
+              <a:rPr sz="1800" b="1">
+                <a:solidFill>
+                  <a:srgbClr val="FFFFFF"/>
+                </a:solidFill>
+              </a:rPr>
+              <a:t>方案确认</a:t>
+            </a:r>
+          </a:p>
+        </p:txBody>
+      </p:sp>
+      <p:sp>
+        <p:nvSpPr>
+          <p:cNvPr id="5" name="Rounded Rectangle 4"/>
           <p:cNvSpPr/>
           <p:nvPr/>
         </p:nvSpPr>
         <p:spPr>
           <a:xfrm>
-            <a:off x="3844204" y="2840879"/>
-            <a:ext cx="2779863" cy="3174558"/>
+            <a:off x="4663440" y="1828800"/>
+            <a:ext cx="1645920" cy="1920240"/>
           </a:xfrm>
-          <a:prstGeom prst="rect">
+          <a:prstGeom prst="roundRect">
             <a:avLst/>
           </a:prstGeom>
           <a:solidFill>
-            <a:srgbClr val="FF0000">
-              <a:alpha val="50000"/>
-            </a:srgbClr>
+            <a:srgbClr val="F1C40F"/>
           </a:solidFill>
           <a:ln>
-            <a:noFill/>
+            <a:solidFill>
+              <a:srgbClr val="F1C40F"/>
+            </a:solidFill>
           </a:ln>
         </p:spPr>
         <p:style>
-          <a:lnRef idx="2">
-            <a:schemeClr val="accent1">
-              <a:shade val="15000"/>
-            </a:schemeClr>
+          <a:lnRef idx="1">
+            <a:schemeClr val="accent1"/>
           </a:lnRef>
-          <a:fillRef idx="1">
+          <a:fillRef idx="3">
             <a:schemeClr val="accent1"/>
           </a:fillRef>
-          <a:effectRef idx="0">
+          <a:effectRef idx="2">
             <a:schemeClr val="accent1"/>
           </a:effectRef>
           <a:fontRef idx="minor">
@@ -5001,83 +4658,58 @@
           <a:lstStyle/>
           <a:p>
             <a:pPr algn="ctr"/>
-            <a:endParaRPr lang="zh-CN" altLang="en-US">
-              <a:solidFill>
-                <a:srgbClr val="92D050"/>
-              </a:solidFill>
-            </a:endParaRPr>
-          </a:p>
-        </p:txBody>
-      </p:sp>
-      <p:cxnSp>
-        <p:nvCxnSpPr>
-          <p:cNvPr id="11" name="直接连接符 10">
-            <a:extLst>
-              <a:ext uri="{FF2B5EF4-FFF2-40B4-BE49-F238E27FC236}">
-                <a16:creationId xmlns:a16="http://schemas.microsoft.com/office/drawing/2014/main" id="{73EAD9B0-774E-C50C-FDFA-F76B4FEE599C}"/>
-              </a:ext>
-            </a:extLst>
-          </p:cNvPr>
-          <p:cNvCxnSpPr>
-            <a:cxnSpLocks/>
-          </p:cNvCxnSpPr>
+            <a:r>
+              <a:rPr sz="1600" b="1">
+                <a:solidFill>
+                  <a:srgbClr val="FFFFFF"/>
+                </a:solidFill>
+              </a:rPr>
+              <a:t>第3-5周</a:t>
+            </a:r>
+          </a:p>
+          <a:p>
+            <a:r>
+              <a:rPr sz="1800" b="1">
+                <a:solidFill>
+                  <a:srgbClr val="FFFFFF"/>
+                </a:solidFill>
+              </a:rPr>
+              <a:t>执行推进</a:t>
+            </a:r>
+          </a:p>
+        </p:txBody>
+      </p:sp>
+      <p:sp>
+        <p:nvSpPr>
+          <p:cNvPr id="6" name="Rounded Rectangle 5"/>
+          <p:cNvSpPr/>
           <p:nvPr/>
-        </p:nvCxnSpPr>
+        </p:nvSpPr>
         <p:spPr>
           <a:xfrm>
-            <a:off x="1517835" y="2087824"/>
-            <a:ext cx="0" cy="4724400"/>
+            <a:off x="7315200" y="1828800"/>
+            <a:ext cx="1645920" cy="1920240"/>
           </a:xfrm>
-          <a:prstGeom prst="line">
+          <a:prstGeom prst="roundRect">
             <a:avLst/>
           </a:prstGeom>
+          <a:solidFill>
+            <a:srgbClr val="E74C3C"/>
+          </a:solidFill>
+          <a:ln>
+            <a:solidFill>
+              <a:srgbClr val="E74C3C"/>
+            </a:solidFill>
+          </a:ln>
         </p:spPr>
         <p:style>
           <a:lnRef idx="1">
             <a:schemeClr val="accent1"/>
           </a:lnRef>
-          <a:fillRef idx="0">
+          <a:fillRef idx="3">
             <a:schemeClr val="accent1"/>
           </a:fillRef>
-          <a:effectRef idx="0">
-            <a:schemeClr val="accent1"/>
-          </a:effectRef>
-          <a:fontRef idx="minor">
-            <a:schemeClr val="tx1"/>
-          </a:fontRef>
-        </p:style>
-      </p:cxnSp>
-      <p:sp>
-        <p:nvSpPr>
-          <p:cNvPr id="12" name="矩形 11">
-            <a:extLst>
-              <a:ext uri="{FF2B5EF4-FFF2-40B4-BE49-F238E27FC236}">
-                <a16:creationId xmlns:a16="http://schemas.microsoft.com/office/drawing/2014/main" id="{5979A094-1A93-5A8A-2229-BA01B741C3E6}"/>
-              </a:ext>
-            </a:extLst>
-          </p:cNvPr>
-          <p:cNvSpPr/>
-          <p:nvPr/>
-        </p:nvSpPr>
-        <p:spPr>
-          <a:xfrm>
-            <a:off x="1517833" y="3365459"/>
-            <a:ext cx="6056634" cy="308540"/>
-          </a:xfrm>
-          <a:prstGeom prst="rect">
-            <a:avLst/>
-          </a:prstGeom>
-        </p:spPr>
-        <p:style>
-          <a:lnRef idx="2">
-            <a:schemeClr val="accent1">
-              <a:shade val="15000"/>
-            </a:schemeClr>
-          </a:lnRef>
-          <a:fillRef idx="1">
-            <a:schemeClr val="accent1"/>
-          </a:fillRef>
-          <a:effectRef idx="0">
+          <a:effectRef idx="2">
             <a:schemeClr val="accent1"/>
           </a:effectRef>
           <a:fontRef idx="minor">
@@ -5089,72 +4721,46 @@
           <a:lstStyle/>
           <a:p>
             <a:pPr algn="ctr"/>
-            <a:endParaRPr lang="zh-CN" altLang="en-US"/>
-          </a:p>
-        </p:txBody>
-      </p:sp>
-      <p:sp>
-        <p:nvSpPr>
-          <p:cNvPr id="13" name="矩形 12">
-            <a:extLst>
-              <a:ext uri="{FF2B5EF4-FFF2-40B4-BE49-F238E27FC236}">
-                <a16:creationId xmlns:a16="http://schemas.microsoft.com/office/drawing/2014/main" id="{B1542EE7-7091-32E7-FA92-CAF3F9B4994D}"/>
-              </a:ext>
-            </a:extLst>
-          </p:cNvPr>
-          <p:cNvSpPr/>
+            <a:r>
+              <a:rPr sz="1600" b="1">
+                <a:solidFill>
+                  <a:srgbClr val="FFFFFF"/>
+                </a:solidFill>
+              </a:rPr>
+              <a:t>第6周</a:t>
+            </a:r>
+          </a:p>
+          <a:p>
+            <a:r>
+              <a:rPr sz="1800" b="1">
+                <a:solidFill>
+                  <a:srgbClr val="FFFFFF"/>
+                </a:solidFill>
+              </a:rPr>
+              <a:t>验收交付</a:t>
+            </a:r>
+            <a:br/>
+            <a:r>
+              <a:rPr sz="1800" b="1">
+                <a:solidFill>
+                  <a:srgbClr val="FFFFFF"/>
+                </a:solidFill>
+              </a:rPr>
+              <a:t>复盘优化</a:t>
+            </a:r>
+          </a:p>
+        </p:txBody>
+      </p:sp>
+      <p:sp>
+        <p:nvSpPr>
+          <p:cNvPr id="7" name="TextBox 6"/>
+          <p:cNvSpPr txBox="1"/>
           <p:nvPr/>
         </p:nvSpPr>
         <p:spPr>
           <a:xfrm>
-            <a:off x="1517833" y="4208739"/>
-            <a:ext cx="9760228" cy="308540"/>
-          </a:xfrm>
-          <a:prstGeom prst="rect">
-            <a:avLst/>
-          </a:prstGeom>
-        </p:spPr>
-        <p:style>
-          <a:lnRef idx="2">
-            <a:schemeClr val="accent1">
-              <a:shade val="15000"/>
-            </a:schemeClr>
-          </a:lnRef>
-          <a:fillRef idx="1">
-            <a:schemeClr val="accent1"/>
-          </a:fillRef>
-          <a:effectRef idx="0">
-            <a:schemeClr val="accent1"/>
-          </a:effectRef>
-          <a:fontRef idx="minor">
-            <a:schemeClr val="lt1"/>
-          </a:fontRef>
-        </p:style>
-        <p:txBody>
-          <a:bodyPr rtlCol="0" anchor="ctr"/>
-          <a:lstStyle/>
-          <a:p>
-            <a:pPr algn="ctr"/>
-            <a:endParaRPr lang="zh-CN" altLang="en-US"/>
-          </a:p>
-        </p:txBody>
-      </p:sp>
-      <p:sp>
-        <p:nvSpPr>
-          <p:cNvPr id="14" name="文本框 13">
-            <a:extLst>
-              <a:ext uri="{FF2B5EF4-FFF2-40B4-BE49-F238E27FC236}">
-                <a16:creationId xmlns:a16="http://schemas.microsoft.com/office/drawing/2014/main" id="{D2542E51-6D18-594C-262C-4F52AAD94587}"/>
-              </a:ext>
-            </a:extLst>
-          </p:cNvPr>
-          <p:cNvSpPr txBox="1"/>
-          <p:nvPr/>
-        </p:nvSpPr>
-        <p:spPr>
-          <a:xfrm>
-            <a:off x="2022301" y="2200799"/>
-            <a:ext cx="1351280" cy="369332"/>
+            <a:off x="2514600" y="2487168"/>
+            <a:ext cx="228600" cy="320040"/>
           </a:xfrm>
           <a:prstGeom prst="rect">
             <a:avLst/>
@@ -5162,36 +4768,32 @@
           <a:noFill/>
         </p:spPr>
         <p:txBody>
-          <a:bodyPr wrap="square" rtlCol="0">
+          <a:bodyPr wrap="none">
             <a:spAutoFit/>
           </a:bodyPr>
           <a:lstStyle/>
           <a:p>
-            <a:pPr algn="ctr"/>
-            <a:r>
-              <a:rPr lang="en-US" altLang="zh-CN" dirty="0"/>
-              <a:t>40ms</a:t>
-            </a:r>
-            <a:endParaRPr lang="zh-CN" altLang="en-US" dirty="0"/>
-          </a:p>
-        </p:txBody>
-      </p:sp>
-      <p:sp>
-        <p:nvSpPr>
-          <p:cNvPr id="15" name="文本框 14">
-            <a:extLst>
-              <a:ext uri="{FF2B5EF4-FFF2-40B4-BE49-F238E27FC236}">
-                <a16:creationId xmlns:a16="http://schemas.microsoft.com/office/drawing/2014/main" id="{0EE432C3-7D29-D37D-FF2E-3ED41BC8169C}"/>
-              </a:ext>
-            </a:extLst>
-          </p:cNvPr>
+            <a:r>
+              <a:rPr sz="2400" b="1">
+                <a:solidFill>
+                  <a:srgbClr val="7F8C8D"/>
+                </a:solidFill>
+              </a:rPr>
+              <a:t>→</a:t>
+            </a:r>
+          </a:p>
+        </p:txBody>
+      </p:sp>
+      <p:sp>
+        <p:nvSpPr>
+          <p:cNvPr id="8" name="TextBox 7"/>
           <p:cNvSpPr txBox="1"/>
           <p:nvPr/>
         </p:nvSpPr>
         <p:spPr>
           <a:xfrm>
-            <a:off x="3203226" y="2221119"/>
-            <a:ext cx="1351280" cy="369332"/>
+            <a:off x="4434840" y="2487168"/>
+            <a:ext cx="228600" cy="320040"/>
           </a:xfrm>
           <a:prstGeom prst="rect">
             <a:avLst/>
@@ -5199,36 +4801,32 @@
           <a:noFill/>
         </p:spPr>
         <p:txBody>
-          <a:bodyPr wrap="square" rtlCol="0">
+          <a:bodyPr wrap="none">
             <a:spAutoFit/>
           </a:bodyPr>
           <a:lstStyle/>
           <a:p>
-            <a:pPr algn="ctr"/>
-            <a:r>
-              <a:rPr lang="en-US" altLang="zh-CN" dirty="0"/>
-              <a:t>80ms</a:t>
-            </a:r>
-            <a:endParaRPr lang="zh-CN" altLang="en-US" dirty="0"/>
-          </a:p>
-        </p:txBody>
-      </p:sp>
-      <p:sp>
-        <p:nvSpPr>
-          <p:cNvPr id="19" name="文本框 18">
-            <a:extLst>
-              <a:ext uri="{FF2B5EF4-FFF2-40B4-BE49-F238E27FC236}">
-                <a16:creationId xmlns:a16="http://schemas.microsoft.com/office/drawing/2014/main" id="{AF2C5C5D-3316-9E32-25BC-C3D7416991F2}"/>
-              </a:ext>
-            </a:extLst>
-          </p:cNvPr>
+            <a:r>
+              <a:rPr sz="2400" b="1">
+                <a:solidFill>
+                  <a:srgbClr val="7F8C8D"/>
+                </a:solidFill>
+              </a:rPr>
+              <a:t>→</a:t>
+            </a:r>
+          </a:p>
+        </p:txBody>
+      </p:sp>
+      <p:sp>
+        <p:nvSpPr>
+          <p:cNvPr id="9" name="TextBox 8"/>
           <p:cNvSpPr txBox="1"/>
           <p:nvPr/>
         </p:nvSpPr>
         <p:spPr>
           <a:xfrm>
-            <a:off x="7146304" y="2221119"/>
-            <a:ext cx="856325" cy="646331"/>
+            <a:off x="7086600" y="2487168"/>
+            <a:ext cx="228600" cy="320040"/>
           </a:xfrm>
           <a:prstGeom prst="rect">
             <a:avLst/>
@@ -5236,151 +4834,32 @@
           <a:noFill/>
         </p:spPr>
         <p:txBody>
-          <a:bodyPr wrap="square" rtlCol="0">
+          <a:bodyPr wrap="none">
             <a:spAutoFit/>
           </a:bodyPr>
           <a:lstStyle/>
           <a:p>
             <a:r>
-              <a:rPr lang="en-US" altLang="zh-CN" dirty="0"/>
-              <a:t>232ms</a:t>
-            </a:r>
-          </a:p>
-          <a:p>
-            <a:endParaRPr lang="zh-CN" altLang="en-US" dirty="0"/>
-          </a:p>
-        </p:txBody>
-      </p:sp>
-      <p:cxnSp>
-        <p:nvCxnSpPr>
-          <p:cNvPr id="20" name="直接连接符 19">
-            <a:extLst>
-              <a:ext uri="{FF2B5EF4-FFF2-40B4-BE49-F238E27FC236}">
-                <a16:creationId xmlns:a16="http://schemas.microsoft.com/office/drawing/2014/main" id="{215A2A0D-91A2-FFA4-D03A-506FBA4F0A7B}"/>
-              </a:ext>
-            </a:extLst>
-          </p:cNvPr>
-          <p:cNvCxnSpPr>
-            <a:cxnSpLocks/>
-          </p:cNvCxnSpPr>
+              <a:rPr sz="2400" b="1">
+                <a:solidFill>
+                  <a:srgbClr val="7F8C8D"/>
+                </a:solidFill>
+              </a:rPr>
+              <a:t>→</a:t>
+            </a:r>
+          </a:p>
+        </p:txBody>
+      </p:sp>
+      <p:sp>
+        <p:nvSpPr>
+          <p:cNvPr id="10" name="TextBox 9"/>
+          <p:cNvSpPr txBox="1"/>
           <p:nvPr/>
-        </p:nvCxnSpPr>
+        </p:nvSpPr>
         <p:spPr>
           <a:xfrm>
-            <a:off x="2681020" y="2484064"/>
-            <a:ext cx="0" cy="4328160"/>
-          </a:xfrm>
-          <a:prstGeom prst="line">
-            <a:avLst/>
-          </a:prstGeom>
-        </p:spPr>
-        <p:style>
-          <a:lnRef idx="1">
-            <a:schemeClr val="accent1"/>
-          </a:lnRef>
-          <a:fillRef idx="0">
-            <a:schemeClr val="accent1"/>
-          </a:fillRef>
-          <a:effectRef idx="0">
-            <a:schemeClr val="accent1"/>
-          </a:effectRef>
-          <a:fontRef idx="minor">
-            <a:schemeClr val="tx1"/>
-          </a:fontRef>
-        </p:style>
-      </p:cxnSp>
-      <p:cxnSp>
-        <p:nvCxnSpPr>
-          <p:cNvPr id="21" name="直接连接符 20">
-            <a:extLst>
-              <a:ext uri="{FF2B5EF4-FFF2-40B4-BE49-F238E27FC236}">
-                <a16:creationId xmlns:a16="http://schemas.microsoft.com/office/drawing/2014/main" id="{1B75C154-FB66-F697-43E6-4ACA05578430}"/>
-              </a:ext>
-            </a:extLst>
-          </p:cNvPr>
-          <p:cNvCxnSpPr>
-            <a:cxnSpLocks/>
-          </p:cNvCxnSpPr>
-          <p:nvPr/>
-        </p:nvCxnSpPr>
-        <p:spPr>
-          <a:xfrm>
-            <a:off x="3844204" y="2484064"/>
-            <a:ext cx="0" cy="4328160"/>
-          </a:xfrm>
-          <a:prstGeom prst="line">
-            <a:avLst/>
-          </a:prstGeom>
-        </p:spPr>
-        <p:style>
-          <a:lnRef idx="1">
-            <a:schemeClr val="accent1"/>
-          </a:lnRef>
-          <a:fillRef idx="0">
-            <a:schemeClr val="accent1"/>
-          </a:fillRef>
-          <a:effectRef idx="0">
-            <a:schemeClr val="accent1"/>
-          </a:effectRef>
-          <a:fontRef idx="minor">
-            <a:schemeClr val="tx1"/>
-          </a:fontRef>
-        </p:style>
-      </p:cxnSp>
-      <p:cxnSp>
-        <p:nvCxnSpPr>
-          <p:cNvPr id="22" name="直接连接符 21">
-            <a:extLst>
-              <a:ext uri="{FF2B5EF4-FFF2-40B4-BE49-F238E27FC236}">
-                <a16:creationId xmlns:a16="http://schemas.microsoft.com/office/drawing/2014/main" id="{12C5F4EB-59FF-EFA5-E7AF-0FCCE70662C1}"/>
-              </a:ext>
-            </a:extLst>
-          </p:cNvPr>
-          <p:cNvCxnSpPr>
-            <a:cxnSpLocks/>
-          </p:cNvCxnSpPr>
-          <p:nvPr/>
-        </p:nvCxnSpPr>
-        <p:spPr>
-          <a:xfrm>
-            <a:off x="7574467" y="2523196"/>
-            <a:ext cx="0" cy="4289028"/>
-          </a:xfrm>
-          <a:prstGeom prst="line">
-            <a:avLst/>
-          </a:prstGeom>
-        </p:spPr>
-        <p:style>
-          <a:lnRef idx="1">
-            <a:schemeClr val="accent1"/>
-          </a:lnRef>
-          <a:fillRef idx="0">
-            <a:schemeClr val="accent1"/>
-          </a:fillRef>
-          <a:effectRef idx="0">
-            <a:schemeClr val="accent1"/>
-          </a:effectRef>
-          <a:fontRef idx="minor">
-            <a:schemeClr val="tx1"/>
-          </a:fontRef>
-        </p:style>
-      </p:cxnSp>
-      <p:sp>
-        <p:nvSpPr>
-          <p:cNvPr id="27" name="文本框 26">
-            <a:extLst>
-              <a:ext uri="{FF2B5EF4-FFF2-40B4-BE49-F238E27FC236}">
-                <a16:creationId xmlns:a16="http://schemas.microsoft.com/office/drawing/2014/main" id="{7433598F-CDFB-3762-ADF1-E6E57E4AE3CE}"/>
-              </a:ext>
-            </a:extLst>
-          </p:cNvPr>
-          <p:cNvSpPr txBox="1"/>
-          <p:nvPr/>
-        </p:nvSpPr>
-        <p:spPr>
-          <a:xfrm>
-            <a:off x="2355900" y="1540399"/>
-            <a:ext cx="650240" cy="646331"/>
+            <a:off x="868680" y="4937760"/>
+            <a:ext cx="10058400" cy="685800"/>
           </a:xfrm>
           <a:prstGeom prst="rect">
             <a:avLst/>
@@ -5388,91 +4867,14 @@
           <a:noFill/>
         </p:spPr>
         <p:txBody>
-          <a:bodyPr wrap="square" rtlCol="0">
+          <a:bodyPr wrap="none">
             <a:spAutoFit/>
           </a:bodyPr>
           <a:lstStyle/>
           <a:p>
             <a:r>
-              <a:rPr lang="zh-CN" altLang="en-US" dirty="0"/>
-              <a:t>转录目标</a:t>
-            </a:r>
-          </a:p>
-        </p:txBody>
-      </p:sp>
-      <p:sp>
-        <p:nvSpPr>
-          <p:cNvPr id="28" name="文本框 27">
-            <a:extLst>
-              <a:ext uri="{FF2B5EF4-FFF2-40B4-BE49-F238E27FC236}">
-                <a16:creationId xmlns:a16="http://schemas.microsoft.com/office/drawing/2014/main" id="{F6D93EAE-0A9B-B680-725F-2C852F9405BE}"/>
-              </a:ext>
-            </a:extLst>
-          </p:cNvPr>
-          <p:cNvSpPr txBox="1"/>
-          <p:nvPr/>
-        </p:nvSpPr>
-        <p:spPr>
-          <a:xfrm>
-            <a:off x="8291021" y="5746639"/>
-            <a:ext cx="1706880" cy="646331"/>
-          </a:xfrm>
-          <a:prstGeom prst="rect">
-            <a:avLst/>
-          </a:prstGeom>
-          <a:noFill/>
-        </p:spPr>
-        <p:txBody>
-          <a:bodyPr wrap="square" rtlCol="0">
-            <a:spAutoFit/>
-          </a:bodyPr>
-          <a:lstStyle/>
-          <a:p>
-            <a:r>
-              <a:rPr lang="zh-CN" altLang="en-US" dirty="0"/>
-              <a:t>真实目标</a:t>
-            </a:r>
-            <a:br>
-              <a:rPr lang="en-US" altLang="zh-CN" dirty="0"/>
-            </a:br>
-            <a:r>
-              <a:rPr lang="zh-CN" altLang="en-US" dirty="0"/>
-              <a:t>创作音乐</a:t>
-            </a:r>
-          </a:p>
-        </p:txBody>
-      </p:sp>
-      <p:sp>
-        <p:nvSpPr>
-          <p:cNvPr id="9" name="文本框 8">
-            <a:extLst>
-              <a:ext uri="{FF2B5EF4-FFF2-40B4-BE49-F238E27FC236}">
-                <a16:creationId xmlns:a16="http://schemas.microsoft.com/office/drawing/2014/main" id="{E08CD24A-E8C0-FC35-B3E6-2361141F165D}"/>
-              </a:ext>
-            </a:extLst>
-          </p:cNvPr>
-          <p:cNvSpPr txBox="1"/>
-          <p:nvPr/>
-        </p:nvSpPr>
-        <p:spPr>
-          <a:xfrm>
-            <a:off x="629283" y="493279"/>
-            <a:ext cx="3906476" cy="523220"/>
-          </a:xfrm>
-          <a:prstGeom prst="rect">
-            <a:avLst/>
-          </a:prstGeom>
-          <a:noFill/>
-        </p:spPr>
-        <p:txBody>
-          <a:bodyPr wrap="square" rtlCol="0">
-            <a:spAutoFit/>
-          </a:bodyPr>
-          <a:lstStyle/>
-          <a:p>
-            <a:r>
-              <a:rPr lang="zh-CN" altLang="en-US" sz="2800" dirty="0"/>
-              <a:t>延迟目标，与训练目标</a:t>
+              <a:rPr sz="1800"/>
+              <a:t>• 后续可在这一页替换为真实项目时间线，补充关键动作、决策点与风险应对。</a:t>
             </a:r>
           </a:p>
         </p:txBody>
@@ -5531,107 +4933,73 @@
         </p:nvSpPr>
         <p:spPr/>
         <p:txBody>
-          <a:bodyPr/>
+          <a:bodyPr wrap="square"/>
           <a:lstStyle/>
           <a:p>
             <a:r>
-              <a:rPr lang="zh-CN" altLang="en-US" dirty="0"/>
-              <a:t>评估与结果</a:t>
-            </a:r>
-          </a:p>
-        </p:txBody>
-      </p:sp>
-      <p:pic>
-        <p:nvPicPr>
-          <p:cNvPr id="11" name="图片 10">
-            <a:extLst>
-              <a:ext uri="{FF2B5EF4-FFF2-40B4-BE49-F238E27FC236}">
-                <a16:creationId xmlns:a16="http://schemas.microsoft.com/office/drawing/2014/main" id="{8E4F8178-2B3C-98D7-FC63-11AE069349C7}"/>
-              </a:ext>
-            </a:extLst>
-          </p:cNvPr>
-          <p:cNvPicPr>
-            <a:picLocks noChangeAspect="1"/>
-          </p:cNvPicPr>
+              <a:rPr sz="2800" b="1"/>
+              <a:t>过程管理与协同机制</a:t>
+            </a:r>
+          </a:p>
+        </p:txBody>
+      </p:sp>
+      <p:sp>
+        <p:nvSpPr>
+          <p:cNvPr id="4" name="TextBox 3"/>
+          <p:cNvSpPr txBox="1"/>
           <p:nvPr/>
-        </p:nvPicPr>
-        <p:blipFill>
-          <a:blip r:embed="rId3"/>
-          <a:stretch>
-            <a:fillRect/>
-          </a:stretch>
-        </p:blipFill>
+        </p:nvSpPr>
         <p:spPr>
           <a:xfrm>
-            <a:off x="4418303" y="1418506"/>
-            <a:ext cx="5960045" cy="2124794"/>
+            <a:off x="868680" y="1325880"/>
+            <a:ext cx="10332720" cy="4480560"/>
           </a:xfrm>
           <a:prstGeom prst="rect">
             <a:avLst/>
           </a:prstGeom>
+          <a:noFill/>
         </p:spPr>
-      </p:pic>
-      <p:pic>
-        <p:nvPicPr>
-          <p:cNvPr id="13" name="图片 12">
-            <a:extLst>
-              <a:ext uri="{FF2B5EF4-FFF2-40B4-BE49-F238E27FC236}">
-                <a16:creationId xmlns:a16="http://schemas.microsoft.com/office/drawing/2014/main" id="{1B2123E0-906D-49B1-F6B5-FE84C0801020}"/>
-              </a:ext>
-            </a:extLst>
-          </p:cNvPr>
-          <p:cNvPicPr>
-            <a:picLocks noChangeAspect="1"/>
-          </p:cNvPicPr>
-          <p:nvPr/>
-        </p:nvPicPr>
-        <p:blipFill>
-          <a:blip r:embed="rId4"/>
-          <a:stretch>
-            <a:fillRect/>
-          </a:stretch>
-        </p:blipFill>
-        <p:spPr>
-          <a:xfrm>
-            <a:off x="4536764" y="4155622"/>
-            <a:ext cx="5049016" cy="2124795"/>
-          </a:xfrm>
-          <a:prstGeom prst="rect">
-            <a:avLst/>
-          </a:prstGeom>
-        </p:spPr>
-      </p:pic>
-      <p:pic>
-        <p:nvPicPr>
-          <p:cNvPr id="17" name="图片 16">
-            <a:extLst>
-              <a:ext uri="{FF2B5EF4-FFF2-40B4-BE49-F238E27FC236}">
-                <a16:creationId xmlns:a16="http://schemas.microsoft.com/office/drawing/2014/main" id="{E4795610-8AF3-148C-A7D2-F41D5E2876CF}"/>
-              </a:ext>
-            </a:extLst>
-          </p:cNvPr>
-          <p:cNvPicPr>
-            <a:picLocks noChangeAspect="1"/>
-          </p:cNvPicPr>
-          <p:nvPr/>
-        </p:nvPicPr>
-        <p:blipFill>
-          <a:blip r:embed="rId5"/>
-          <a:srcRect b="32609"/>
-          <a:stretch>
-            <a:fillRect/>
-          </a:stretch>
-        </p:blipFill>
-        <p:spPr>
-          <a:xfrm>
-            <a:off x="339109" y="1247056"/>
-            <a:ext cx="4140245" cy="5234825"/>
-          </a:xfrm>
-          <a:prstGeom prst="rect">
-            <a:avLst/>
-          </a:prstGeom>
-        </p:spPr>
-      </p:pic>
+        <p:txBody>
+          <a:bodyPr wrap="square">
+            <a:spAutoFit/>
+          </a:bodyPr>
+          <a:lstStyle/>
+          <a:p>
+            <a:r>
+              <a:rPr sz="2400"/>
+              <a:t>• 用周会 / 双周会 / 阶段复盘管理项目节奏</a:t>
+            </a:r>
+          </a:p>
+          <a:p>
+            <a:pPr>
+              <a:spcBef>
+                <a:spcPts val="0"/>
+              </a:spcBef>
+              <a:spcAft>
+                <a:spcPts val="800"/>
+              </a:spcAft>
+            </a:pPr>
+            <a:r>
+              <a:rPr sz="2400"/>
+              <a:t>• 跟踪进度、问题、风险、决策项并形成闭环</a:t>
+            </a:r>
+          </a:p>
+          <a:p>
+            <a:pPr>
+              <a:spcBef>
+                <a:spcPts val="0"/>
+              </a:spcBef>
+              <a:spcAft>
+                <a:spcPts val="800"/>
+              </a:spcAft>
+            </a:pPr>
+            <a:r>
+              <a:rPr sz="2400"/>
+              <a:t>• 展示跨部门协同方式：产品、研发、运营、业务方</a:t>
+            </a:r>
+          </a:p>
+        </p:txBody>
+      </p:sp>
     </p:spTree>
     <p:extLst>
       <p:ext uri="{BB962C8B-B14F-4D97-AF65-F5344CB8AC3E}">
@@ -5694,92 +5062,26 @@
         </p:nvSpPr>
         <p:spPr/>
         <p:txBody>
-          <a:bodyPr/>
+          <a:bodyPr wrap="square"/>
           <a:lstStyle/>
           <a:p>
             <a:r>
-              <a:rPr lang="zh-CN" altLang="en-US" dirty="0"/>
-              <a:t>评估与结果</a:t>
-            </a:r>
-          </a:p>
-        </p:txBody>
-      </p:sp>
-      <p:pic>
-        <p:nvPicPr>
-          <p:cNvPr id="7" name="图片 6">
-            <a:extLst>
-              <a:ext uri="{FF2B5EF4-FFF2-40B4-BE49-F238E27FC236}">
-                <a16:creationId xmlns:a16="http://schemas.microsoft.com/office/drawing/2014/main" id="{C236F4D9-8709-B22B-0B4D-C79048BC503D}"/>
-              </a:ext>
-            </a:extLst>
-          </p:cNvPr>
-          <p:cNvPicPr>
-            <a:picLocks noChangeAspect="1"/>
-          </p:cNvPicPr>
+              <a:rPr sz="2800" b="1"/>
+              <a:t>风险管理与应对预案</a:t>
+            </a:r>
+          </a:p>
+        </p:txBody>
+      </p:sp>
+      <p:sp>
+        <p:nvSpPr>
+          <p:cNvPr id="4" name="TextBox 3"/>
+          <p:cNvSpPr txBox="1"/>
           <p:nvPr/>
-        </p:nvPicPr>
-        <p:blipFill>
-          <a:blip r:embed="rId3"/>
-          <a:stretch>
-            <a:fillRect/>
-          </a:stretch>
-        </p:blipFill>
+        </p:nvSpPr>
         <p:spPr>
           <a:xfrm>
-            <a:off x="1675952" y="1231126"/>
-            <a:ext cx="6513452" cy="2605380"/>
-          </a:xfrm>
-          <a:prstGeom prst="rect">
-            <a:avLst/>
-          </a:prstGeom>
-        </p:spPr>
-      </p:pic>
-      <p:pic>
-        <p:nvPicPr>
-          <p:cNvPr id="9" name="图片 8">
-            <a:extLst>
-              <a:ext uri="{FF2B5EF4-FFF2-40B4-BE49-F238E27FC236}">
-                <a16:creationId xmlns:a16="http://schemas.microsoft.com/office/drawing/2014/main" id="{4C8DC6EF-5BA5-0ABC-E26E-6F2B03A06878}"/>
-              </a:ext>
-            </a:extLst>
-          </p:cNvPr>
-          <p:cNvPicPr>
-            <a:picLocks noChangeAspect="1"/>
-          </p:cNvPicPr>
-          <p:nvPr/>
-        </p:nvPicPr>
-        <p:blipFill>
-          <a:blip r:embed="rId4"/>
-          <a:stretch>
-            <a:fillRect/>
-          </a:stretch>
-        </p:blipFill>
-        <p:spPr>
-          <a:xfrm>
-            <a:off x="1675952" y="3804563"/>
-            <a:ext cx="6513452" cy="2605381"/>
-          </a:xfrm>
-          <a:prstGeom prst="rect">
-            <a:avLst/>
-          </a:prstGeom>
-        </p:spPr>
-      </p:pic>
-      <p:sp>
-        <p:nvSpPr>
-          <p:cNvPr id="2" name="文本框 1">
-            <a:extLst>
-              <a:ext uri="{FF2B5EF4-FFF2-40B4-BE49-F238E27FC236}">
-                <a16:creationId xmlns:a16="http://schemas.microsoft.com/office/drawing/2014/main" id="{74A6E956-85CB-E21F-E397-F564DC4FD9AC}"/>
-              </a:ext>
-            </a:extLst>
-          </p:cNvPr>
-          <p:cNvSpPr txBox="1"/>
-          <p:nvPr/>
-        </p:nvSpPr>
-        <p:spPr>
-          <a:xfrm>
-            <a:off x="7762460" y="1658508"/>
-            <a:ext cx="853888" cy="3016210"/>
+            <a:off x="868680" y="1325880"/>
+            <a:ext cx="10332720" cy="4480560"/>
           </a:xfrm>
           <a:prstGeom prst="rect">
             <a:avLst/>
@@ -5787,51 +5089,43 @@
           <a:noFill/>
         </p:spPr>
         <p:txBody>
-          <a:bodyPr wrap="none" rtlCol="0">
+          <a:bodyPr wrap="square">
             <a:spAutoFit/>
           </a:bodyPr>
           <a:lstStyle/>
           <a:p>
-            <a:pPr algn="ctr"/>
-            <a:r>
-              <a:rPr lang="en-US" altLang="zh-CN" sz="1900" dirty="0"/>
-              <a:t>Partial</a:t>
-            </a:r>
-          </a:p>
-          <a:p>
-            <a:pPr algn="ctr"/>
-            <a:endParaRPr lang="en-US" altLang="zh-CN" sz="1900" dirty="0"/>
-          </a:p>
-          <a:p>
-            <a:pPr algn="ctr"/>
-            <a:endParaRPr lang="en-US" altLang="zh-CN" sz="1900" dirty="0"/>
-          </a:p>
-          <a:p>
-            <a:pPr algn="ctr"/>
-            <a:br>
-              <a:rPr lang="en-US" altLang="zh-CN" sz="1900" dirty="0"/>
-            </a:br>
-            <a:br>
-              <a:rPr lang="en-US" altLang="zh-CN" sz="1900" dirty="0"/>
-            </a:br>
-            <a:br>
-              <a:rPr lang="en-US" altLang="zh-CN" sz="1900" dirty="0"/>
-            </a:br>
-            <a:br>
-              <a:rPr lang="en-US" altLang="zh-CN" sz="1900" dirty="0"/>
-            </a:br>
-            <a:endParaRPr lang="en-US" altLang="zh-CN" sz="1900" dirty="0"/>
-          </a:p>
-          <a:p>
-            <a:pPr algn="ctr"/>
-            <a:br>
-              <a:rPr lang="en-US" altLang="zh-CN" sz="1900" dirty="0"/>
-            </a:br>
-            <a:r>
-              <a:rPr lang="en-US" altLang="zh-CN" sz="1900" dirty="0"/>
-              <a:t>Full</a:t>
-            </a:r>
-            <a:endParaRPr lang="zh-CN" altLang="en-US" sz="1900" dirty="0"/>
+            <a:r>
+              <a:rPr sz="2400"/>
+              <a:t>• 范围变更：建立变更评估、影响分析与确认机制</a:t>
+            </a:r>
+          </a:p>
+          <a:p>
+            <a:pPr>
+              <a:spcBef>
+                <a:spcPts val="0"/>
+              </a:spcBef>
+              <a:spcAft>
+                <a:spcPts val="800"/>
+              </a:spcAft>
+            </a:pPr>
+            <a:r>
+              <a:rPr sz="2400"/>
+              <a:t>• 资源不足：识别关键岗位缺口，准备替代方案</a:t>
+            </a:r>
+          </a:p>
+          <a:p>
+            <a:pPr>
+              <a:spcBef>
+                <a:spcPts val="0"/>
+              </a:spcBef>
+              <a:spcAft>
+                <a:spcPts val="800"/>
+              </a:spcAft>
+            </a:pPr>
+            <a:r>
+              <a:rPr sz="2400"/>
+              <a:t>• 节点延误：设置预警阈值、升级路径和补救动作</a:t>
+            </a:r>
           </a:p>
         </p:txBody>
       </p:sp>

</xml_diff>